<commit_message>
Typeset Evidence Room SKU books and thicken Monday-ready Office files.
Replace cover-stub PDFs with full Diagnostic, Starter, 217-page Professional OS, Team, Blueprint, and legal-draft books. Expand Word templates, workshop/CFO decks, and example workbooks so a purchaser can start Wave 1 without living in Markdown.

Co-authored-by: adamaziz91 <adamaziz91@gmail.com>
</commit_message>
<xml_diff>
--- a/evidence-room/04_AP_AGENT_OS_TEAM/Decks/ER_Business_Case_Deck.pptx
+++ b/evidence-room/04_AP_AGENT_OS_TEAM/Decks/ER_Business_Case_Deck.pptx
@@ -7,6 +7,12 @@
   <p:sldIdLst>
     <p:sldId id="256" r:id="rId7"/>
     <p:sldId id="257" r:id="rId8"/>
+    <p:sldId id="258" r:id="rId9"/>
+    <p:sldId id="259" r:id="rId10"/>
+    <p:sldId id="260" r:id="rId11"/>
+    <p:sldId id="261" r:id="rId12"/>
+    <p:sldId id="262" r:id="rId13"/>
+    <p:sldId id="263" r:id="rId14"/>
   </p:sldIdLst>
   <p:sldSz cx="9144000" cy="6858000" type="screen4x3"/>
   <p:notesSz cx="6858000" cy="9144000"/>
@@ -3091,20 +3097,198 @@
       <p:grpSpPr/>
       <p:sp>
         <p:nvSpPr>
-          <p:cNvPr id="2" name="Title 1"/>
-          <p:cNvSpPr>
-            <a:spLocks noGrp="1"/>
-          </p:cNvSpPr>
-          <p:nvPr>
-            <p:ph type="ctrTitle"/>
-          </p:nvPr>
-        </p:nvSpPr>
-        <p:spPr/>
-        <p:txBody>
-          <a:bodyPr/>
-          <a:lstStyle/>
-          <a:p>
-            <a:r>
+          <p:cNvPr id="2" name="Rectangle 1"/>
+          <p:cNvSpPr/>
+          <p:nvPr/>
+        </p:nvSpPr>
+        <p:spPr>
+          <a:xfrm>
+            <a:off x="0" y="0"/>
+            <a:ext cx="9144000" cy="6858000"/>
+          </a:xfrm>
+          <a:prstGeom prst="rect">
+            <a:avLst/>
+          </a:prstGeom>
+          <a:solidFill>
+            <a:srgbClr val="F3EEE4"/>
+          </a:solidFill>
+          <a:ln>
+            <a:noFill/>
+          </a:ln>
+        </p:spPr>
+        <p:style>
+          <a:lnRef idx="1">
+            <a:schemeClr val="accent1"/>
+          </a:lnRef>
+          <a:fillRef idx="3">
+            <a:schemeClr val="accent1"/>
+          </a:fillRef>
+          <a:effectRef idx="2">
+            <a:schemeClr val="accent1"/>
+          </a:effectRef>
+          <a:fontRef idx="minor">
+            <a:schemeClr val="lt1"/>
+          </a:fontRef>
+        </p:style>
+        <p:txBody>
+          <a:bodyPr rtlCol="0" anchor="ctr"/>
+          <a:lstStyle/>
+          <a:p>
+            <a:pPr algn="ctr"/>
+          </a:p>
+        </p:txBody>
+      </p:sp>
+      <p:sp>
+        <p:nvSpPr>
+          <p:cNvPr id="3" name="Rectangle 2"/>
+          <p:cNvSpPr/>
+          <p:nvPr/>
+        </p:nvSpPr>
+        <p:spPr>
+          <a:xfrm>
+            <a:off x="457200" y="640080"/>
+            <a:ext cx="347472" cy="347472"/>
+          </a:xfrm>
+          <a:prstGeom prst="rect">
+            <a:avLst/>
+          </a:prstGeom>
+          <a:solidFill>
+            <a:srgbClr val="F3EEE4"/>
+          </a:solidFill>
+          <a:ln>
+            <a:noFill/>
+          </a:ln>
+        </p:spPr>
+        <p:style>
+          <a:lnRef idx="1">
+            <a:schemeClr val="accent1"/>
+          </a:lnRef>
+          <a:fillRef idx="3">
+            <a:schemeClr val="accent1"/>
+          </a:fillRef>
+          <a:effectRef idx="2">
+            <a:schemeClr val="accent1"/>
+          </a:effectRef>
+          <a:fontRef idx="minor">
+            <a:schemeClr val="lt1"/>
+          </a:fontRef>
+        </p:style>
+        <p:txBody>
+          <a:bodyPr rtlCol="0" anchor="ctr"/>
+          <a:lstStyle/>
+          <a:p>
+            <a:pPr algn="ctr"/>
+          </a:p>
+        </p:txBody>
+      </p:sp>
+      <p:sp>
+        <p:nvSpPr>
+          <p:cNvPr id="4" name="Rectangle 3"/>
+          <p:cNvSpPr/>
+          <p:nvPr/>
+        </p:nvSpPr>
+        <p:spPr>
+          <a:xfrm>
+            <a:off x="457200" y="640080"/>
+            <a:ext cx="347472" cy="347472"/>
+          </a:xfrm>
+          <a:prstGeom prst="rect">
+            <a:avLst/>
+          </a:prstGeom>
+          <a:noFill/>
+          <a:ln w="12700">
+            <a:solidFill>
+              <a:srgbClr val="B0893E"/>
+            </a:solidFill>
+          </a:ln>
+        </p:spPr>
+        <p:style>
+          <a:lnRef idx="1">
+            <a:schemeClr val="accent1"/>
+          </a:lnRef>
+          <a:fillRef idx="3">
+            <a:schemeClr val="accent1"/>
+          </a:fillRef>
+          <a:effectRef idx="2">
+            <a:schemeClr val="accent1"/>
+          </a:effectRef>
+          <a:fontRef idx="minor">
+            <a:schemeClr val="lt1"/>
+          </a:fontRef>
+        </p:style>
+        <p:txBody>
+          <a:bodyPr rtlCol="0" anchor="ctr"/>
+          <a:lstStyle/>
+          <a:p>
+            <a:pPr algn="ctr"/>
+          </a:p>
+        </p:txBody>
+      </p:sp>
+      <p:sp>
+        <p:nvSpPr>
+          <p:cNvPr id="5" name="TextBox 4"/>
+          <p:cNvSpPr txBox="1"/>
+          <p:nvPr/>
+        </p:nvSpPr>
+        <p:spPr>
+          <a:xfrm>
+            <a:off x="457200" y="1280160"/>
+            <a:ext cx="8229600" cy="320040"/>
+          </a:xfrm>
+          <a:prstGeom prst="rect">
+            <a:avLst/>
+          </a:prstGeom>
+          <a:noFill/>
+        </p:spPr>
+        <p:txBody>
+          <a:bodyPr wrap="square">
+            <a:spAutoFit/>
+          </a:bodyPr>
+          <a:lstStyle/>
+          <a:p>
+            <a:pPr algn="l"/>
+            <a:r>
+              <a:rPr sz="1200" b="1">
+                <a:solidFill>
+                  <a:srgbClr val="B0893E"/>
+                </a:solidFill>
+                <a:latin typeface="Calibri"/>
+              </a:rPr>
+              <a:t>BUSINESS CASE</a:t>
+            </a:r>
+          </a:p>
+        </p:txBody>
+      </p:sp>
+      <p:sp>
+        <p:nvSpPr>
+          <p:cNvPr id="6" name="TextBox 5"/>
+          <p:cNvSpPr txBox="1"/>
+          <p:nvPr/>
+        </p:nvSpPr>
+        <p:spPr>
+          <a:xfrm>
+            <a:off x="457200" y="1737360"/>
+            <a:ext cx="8229600" cy="2011680"/>
+          </a:xfrm>
+          <a:prstGeom prst="rect">
+            <a:avLst/>
+          </a:prstGeom>
+          <a:noFill/>
+        </p:spPr>
+        <p:txBody>
+          <a:bodyPr wrap="square">
+            <a:spAutoFit/>
+          </a:bodyPr>
+          <a:lstStyle/>
+          <a:p>
+            <a:pPr algn="l"/>
+            <a:r>
+              <a:rPr sz="3600" b="0">
+                <a:solidFill>
+                  <a:srgbClr val="12160F"/>
+                </a:solidFill>
+                <a:latin typeface="Georgia"/>
+              </a:rPr>
               <a:t>Arithmetic on your inputs</a:t>
             </a:r>
           </a:p>
@@ -3112,26 +3296,70 @@
       </p:sp>
       <p:sp>
         <p:nvSpPr>
-          <p:cNvPr id="3" name="Subtitle 2"/>
-          <p:cNvSpPr>
-            <a:spLocks noGrp="1"/>
-          </p:cNvSpPr>
-          <p:nvPr>
-            <p:ph type="subTitle" idx="1"/>
-          </p:nvPr>
-        </p:nvSpPr>
-        <p:spPr/>
-        <p:txBody>
-          <a:bodyPr/>
-          <a:lstStyle/>
-          <a:p>
-            <a:r>
-              <a:t>BUSINESS CASE</a:t>
-            </a:r>
-          </a:p>
-          <a:p>
-            <a:r>
-              <a:t>Not a forecast. Duplicate-suspect savings = 0.</a:t>
+          <p:cNvPr id="7" name="TextBox 6"/>
+          <p:cNvSpPr txBox="1"/>
+          <p:nvPr/>
+        </p:nvSpPr>
+        <p:spPr>
+          <a:xfrm>
+            <a:off x="457200" y="4023360"/>
+            <a:ext cx="7772400" cy="1097280"/>
+          </a:xfrm>
+          <a:prstGeom prst="rect">
+            <a:avLst/>
+          </a:prstGeom>
+          <a:noFill/>
+        </p:spPr>
+        <p:txBody>
+          <a:bodyPr wrap="square">
+            <a:spAutoFit/>
+          </a:bodyPr>
+          <a:lstStyle/>
+          <a:p>
+            <a:pPr algn="l"/>
+            <a:r>
+              <a:rPr sz="1600" b="0">
+                <a:solidFill>
+                  <a:srgbClr val="5A6154"/>
+                </a:solidFill>
+                <a:latin typeface="Calibri"/>
+              </a:rPr>
+              <a:t>Not a forecast. Duplicate-suspect savings equal zero. Leave unknowns blank.</a:t>
+            </a:r>
+          </a:p>
+        </p:txBody>
+      </p:sp>
+      <p:sp>
+        <p:nvSpPr>
+          <p:cNvPr id="8" name="TextBox 7"/>
+          <p:cNvSpPr txBox="1"/>
+          <p:nvPr/>
+        </p:nvSpPr>
+        <p:spPr>
+          <a:xfrm>
+            <a:off x="457200" y="6217920"/>
+            <a:ext cx="8229600" cy="274320"/>
+          </a:xfrm>
+          <a:prstGeom prst="rect">
+            <a:avLst/>
+          </a:prstGeom>
+          <a:noFill/>
+        </p:spPr>
+        <p:txBody>
+          <a:bodyPr wrap="square">
+            <a:spAutoFit/>
+          </a:bodyPr>
+          <a:lstStyle/>
+          <a:p>
+            <a:pPr algn="l"/>
+            <a:r>
+              <a:rPr sz="1100" b="0">
+                <a:solidFill>
+                  <a:srgbClr val="5A6154"/>
+                </a:solidFill>
+                <a:latin typeface="Calibri"/>
+              </a:rPr>
+              <a:t>Proof before permission.  ·  Working draft. Not a forecast.</a:t>
             </a:r>
           </a:p>
         </p:txBody>
@@ -3156,20 +3384,155 @@
       <p:grpSpPr/>
       <p:sp>
         <p:nvSpPr>
-          <p:cNvPr id="2" name="Title 1"/>
-          <p:cNvSpPr>
-            <a:spLocks noGrp="1"/>
-          </p:cNvSpPr>
-          <p:nvPr>
-            <p:ph type="title"/>
-          </p:nvPr>
-        </p:nvSpPr>
-        <p:spPr/>
-        <p:txBody>
-          <a:bodyPr/>
-          <a:lstStyle/>
-          <a:p>
-            <a:r>
+          <p:cNvPr id="2" name="Rectangle 1"/>
+          <p:cNvSpPr/>
+          <p:nvPr/>
+        </p:nvSpPr>
+        <p:spPr>
+          <a:xfrm>
+            <a:off x="0" y="0"/>
+            <a:ext cx="9144000" cy="6858000"/>
+          </a:xfrm>
+          <a:prstGeom prst="rect">
+            <a:avLst/>
+          </a:prstGeom>
+          <a:solidFill>
+            <a:srgbClr val="F3EEE4"/>
+          </a:solidFill>
+          <a:ln>
+            <a:noFill/>
+          </a:ln>
+        </p:spPr>
+        <p:style>
+          <a:lnRef idx="1">
+            <a:schemeClr val="accent1"/>
+          </a:lnRef>
+          <a:fillRef idx="3">
+            <a:schemeClr val="accent1"/>
+          </a:fillRef>
+          <a:effectRef idx="2">
+            <a:schemeClr val="accent1"/>
+          </a:effectRef>
+          <a:fontRef idx="minor">
+            <a:schemeClr val="lt1"/>
+          </a:fontRef>
+        </p:style>
+        <p:txBody>
+          <a:bodyPr rtlCol="0" anchor="ctr"/>
+          <a:lstStyle/>
+          <a:p>
+            <a:pPr algn="ctr"/>
+          </a:p>
+        </p:txBody>
+      </p:sp>
+      <p:sp>
+        <p:nvSpPr>
+          <p:cNvPr id="3" name="Rectangle 2"/>
+          <p:cNvSpPr/>
+          <p:nvPr/>
+        </p:nvSpPr>
+        <p:spPr>
+          <a:xfrm>
+            <a:off x="0" y="0"/>
+            <a:ext cx="73152" cy="6858000"/>
+          </a:xfrm>
+          <a:prstGeom prst="rect">
+            <a:avLst/>
+          </a:prstGeom>
+          <a:solidFill>
+            <a:srgbClr val="B0893E"/>
+          </a:solidFill>
+          <a:ln>
+            <a:noFill/>
+          </a:ln>
+        </p:spPr>
+        <p:style>
+          <a:lnRef idx="1">
+            <a:schemeClr val="accent1"/>
+          </a:lnRef>
+          <a:fillRef idx="3">
+            <a:schemeClr val="accent1"/>
+          </a:fillRef>
+          <a:effectRef idx="2">
+            <a:schemeClr val="accent1"/>
+          </a:effectRef>
+          <a:fontRef idx="minor">
+            <a:schemeClr val="lt1"/>
+          </a:fontRef>
+        </p:style>
+        <p:txBody>
+          <a:bodyPr rtlCol="0" anchor="ctr"/>
+          <a:lstStyle/>
+          <a:p>
+            <a:pPr algn="ctr"/>
+          </a:p>
+        </p:txBody>
+      </p:sp>
+      <p:sp>
+        <p:nvSpPr>
+          <p:cNvPr id="4" name="TextBox 3"/>
+          <p:cNvSpPr txBox="1"/>
+          <p:nvPr/>
+        </p:nvSpPr>
+        <p:spPr>
+          <a:xfrm>
+            <a:off x="365760" y="164592"/>
+            <a:ext cx="8412480" cy="256032"/>
+          </a:xfrm>
+          <a:prstGeom prst="rect">
+            <a:avLst/>
+          </a:prstGeom>
+          <a:noFill/>
+        </p:spPr>
+        <p:txBody>
+          <a:bodyPr wrap="square">
+            <a:spAutoFit/>
+          </a:bodyPr>
+          <a:lstStyle/>
+          <a:p>
+            <a:pPr algn="l"/>
+            <a:r>
+              <a:rPr sz="1000" b="0">
+                <a:solidFill>
+                  <a:srgbClr val="B0893E"/>
+                </a:solidFill>
+                <a:latin typeface="Calibri"/>
+              </a:rPr>
+              <a:t>EVIDENCE ROOM — AP AGENT OS   ·   Use</a:t>
+            </a:r>
+          </a:p>
+        </p:txBody>
+      </p:sp>
+      <p:sp>
+        <p:nvSpPr>
+          <p:cNvPr id="5" name="TextBox 4"/>
+          <p:cNvSpPr txBox="1"/>
+          <p:nvPr/>
+        </p:nvSpPr>
+        <p:spPr>
+          <a:xfrm>
+            <a:off x="365760" y="502920"/>
+            <a:ext cx="8412480" cy="731520"/>
+          </a:xfrm>
+          <a:prstGeom prst="rect">
+            <a:avLst/>
+          </a:prstGeom>
+          <a:noFill/>
+        </p:spPr>
+        <p:txBody>
+          <a:bodyPr wrap="square">
+            <a:spAutoFit/>
+          </a:bodyPr>
+          <a:lstStyle/>
+          <a:p>
+            <a:pPr algn="l"/>
+            <a:r>
+              <a:rPr sz="2600" b="0">
+                <a:solidFill>
+                  <a:srgbClr val="12160F"/>
+                </a:solidFill>
+                <a:latin typeface="Georgia"/>
+              </a:rPr>
               <a:t>How to use the workbook</a:t>
             </a:r>
           </a:p>
@@ -3177,46 +3540,1944 @@
       </p:sp>
       <p:sp>
         <p:nvSpPr>
-          <p:cNvPr id="3" name="Content Placeholder 2"/>
-          <p:cNvSpPr>
-            <a:spLocks noGrp="1"/>
-          </p:cNvSpPr>
-          <p:nvPr>
-            <p:ph idx="1"/>
-          </p:nvPr>
-        </p:nvSpPr>
-        <p:spPr/>
-        <p:txBody>
-          <a:bodyPr/>
-          <a:lstStyle/>
-          <a:p>
-            <a:pPr/>
-            <a:r>
-              <a:t>Enter volume, FTE, loaded cost, touch and exception times.</a:t>
-            </a:r>
-          </a:p>
-          <a:p>
-            <a:pPr/>
-            <a:r>
-              <a:t>Leave unknowns blank.</a:t>
-            </a:r>
-          </a:p>
-          <a:p>
-            <a:pPr/>
-            <a:r>
-              <a:t>Read Conservative / Base / Upside as envelopes.</a:t>
-            </a:r>
-          </a:p>
-          <a:p>
-            <a:pPr/>
-            <a:r>
-              <a:t>Do not paste vendor $2.78 as a target.</a:t>
-            </a:r>
-          </a:p>
-          <a:p>
-            <a:pPr/>
-            <a:r>
-              <a:t>Validated savings require a Finance attestation method.</a:t>
+          <p:cNvPr id="6" name="TextBox 5"/>
+          <p:cNvSpPr txBox="1"/>
+          <p:nvPr/>
+        </p:nvSpPr>
+        <p:spPr>
+          <a:xfrm>
+            <a:off x="365760" y="1371600"/>
+            <a:ext cx="8321040" cy="4937760"/>
+          </a:xfrm>
+          <a:prstGeom prst="rect">
+            <a:avLst/>
+          </a:prstGeom>
+          <a:noFill/>
+        </p:spPr>
+        <p:txBody>
+          <a:bodyPr wrap="square">
+            <a:spAutoFit/>
+          </a:bodyPr>
+          <a:lstStyle/>
+          <a:p>
+            <a:pPr>
+              <a:spcAft>
+                <a:spcPts val="800"/>
+              </a:spcAft>
+            </a:pPr>
+            <a:r>
+              <a:rPr sz="1600">
+                <a:solidFill>
+                  <a:srgbClr val="12160F"/>
+                </a:solidFill>
+                <a:latin typeface="Calibri"/>
+              </a:rPr>
+              <a:t>·  Enter volume, path FTE, loaded cost, hours, touch and exception times.</a:t>
+            </a:r>
+          </a:p>
+          <a:p>
+            <a:pPr>
+              <a:spcAft>
+                <a:spcPts val="800"/>
+              </a:spcAft>
+            </a:pPr>
+            <a:r>
+              <a:rPr sz="1600">
+                <a:solidFill>
+                  <a:srgbClr val="12160F"/>
+                </a:solidFill>
+                <a:latin typeface="Calibri"/>
+              </a:rPr>
+              <a:t>·  Leave unknowns blank. Do not fill with industry averages.</a:t>
+            </a:r>
+          </a:p>
+          <a:p>
+            <a:pPr>
+              <a:spcAft>
+                <a:spcPts val="800"/>
+              </a:spcAft>
+            </a:pPr>
+            <a:r>
+              <a:rPr sz="1600">
+                <a:solidFill>
+                  <a:srgbClr val="12160F"/>
+                </a:solidFill>
+                <a:latin typeface="Calibri"/>
+              </a:rPr>
+              <a:t>·  Read Conservative / Base / Upside as envelopes.</a:t>
+            </a:r>
+          </a:p>
+          <a:p>
+            <a:pPr>
+              <a:spcAft>
+                <a:spcPts val="800"/>
+              </a:spcAft>
+            </a:pPr>
+            <a:r>
+              <a:rPr sz="1600">
+                <a:solidFill>
+                  <a:srgbClr val="12160F"/>
+                </a:solidFill>
+                <a:latin typeface="Calibri"/>
+              </a:rPr>
+              <a:t>·  Do not paste vendor $2.78 / $12.88 into INPUTS.</a:t>
+            </a:r>
+          </a:p>
+          <a:p>
+            <a:pPr>
+              <a:spcAft>
+                <a:spcPts val="800"/>
+              </a:spcAft>
+            </a:pPr>
+            <a:r>
+              <a:rPr sz="1600">
+                <a:solidFill>
+                  <a:srgbClr val="12160F"/>
+                </a:solidFill>
+                <a:latin typeface="Calibri"/>
+              </a:rPr>
+              <a:t>·  Validated savings require a Finance attestation method.</a:t>
+            </a:r>
+          </a:p>
+        </p:txBody>
+      </p:sp>
+    </p:spTree>
+  </p:cSld>
+  <p:clrMapOvr>
+    <a:masterClrMapping/>
+  </p:clrMapOvr>
+</p:sld>
+</file>
+
+<file path=ppt/slides/slide3.xml><?xml version="1.0" encoding="utf-8"?>
+<p:sld xmlns:a="http://schemas.openxmlformats.org/drawingml/2006/main" xmlns:p="http://schemas.openxmlformats.org/presentationml/2006/main" xmlns:r="http://schemas.openxmlformats.org/officeDocument/2006/relationships">
+  <p:cSld>
+    <p:spTree>
+      <p:nvGrpSpPr>
+        <p:cNvPr id="1" name=""/>
+        <p:cNvGrpSpPr/>
+        <p:nvPr/>
+      </p:nvGrpSpPr>
+      <p:grpSpPr/>
+      <p:sp>
+        <p:nvSpPr>
+          <p:cNvPr id="2" name="Rectangle 1"/>
+          <p:cNvSpPr/>
+          <p:nvPr/>
+        </p:nvSpPr>
+        <p:spPr>
+          <a:xfrm>
+            <a:off x="0" y="0"/>
+            <a:ext cx="9144000" cy="6858000"/>
+          </a:xfrm>
+          <a:prstGeom prst="rect">
+            <a:avLst/>
+          </a:prstGeom>
+          <a:solidFill>
+            <a:srgbClr val="F3EEE4"/>
+          </a:solidFill>
+          <a:ln>
+            <a:noFill/>
+          </a:ln>
+        </p:spPr>
+        <p:style>
+          <a:lnRef idx="1">
+            <a:schemeClr val="accent1"/>
+          </a:lnRef>
+          <a:fillRef idx="3">
+            <a:schemeClr val="accent1"/>
+          </a:fillRef>
+          <a:effectRef idx="2">
+            <a:schemeClr val="accent1"/>
+          </a:effectRef>
+          <a:fontRef idx="minor">
+            <a:schemeClr val="lt1"/>
+          </a:fontRef>
+        </p:style>
+        <p:txBody>
+          <a:bodyPr rtlCol="0" anchor="ctr"/>
+          <a:lstStyle/>
+          <a:p>
+            <a:pPr algn="ctr"/>
+          </a:p>
+        </p:txBody>
+      </p:sp>
+      <p:sp>
+        <p:nvSpPr>
+          <p:cNvPr id="3" name="Rectangle 2"/>
+          <p:cNvSpPr/>
+          <p:nvPr/>
+        </p:nvSpPr>
+        <p:spPr>
+          <a:xfrm>
+            <a:off x="0" y="0"/>
+            <a:ext cx="73152" cy="6858000"/>
+          </a:xfrm>
+          <a:prstGeom prst="rect">
+            <a:avLst/>
+          </a:prstGeom>
+          <a:solidFill>
+            <a:srgbClr val="B0893E"/>
+          </a:solidFill>
+          <a:ln>
+            <a:noFill/>
+          </a:ln>
+        </p:spPr>
+        <p:style>
+          <a:lnRef idx="1">
+            <a:schemeClr val="accent1"/>
+          </a:lnRef>
+          <a:fillRef idx="3">
+            <a:schemeClr val="accent1"/>
+          </a:fillRef>
+          <a:effectRef idx="2">
+            <a:schemeClr val="accent1"/>
+          </a:effectRef>
+          <a:fontRef idx="minor">
+            <a:schemeClr val="lt1"/>
+          </a:fontRef>
+        </p:style>
+        <p:txBody>
+          <a:bodyPr rtlCol="0" anchor="ctr"/>
+          <a:lstStyle/>
+          <a:p>
+            <a:pPr algn="ctr"/>
+          </a:p>
+        </p:txBody>
+      </p:sp>
+      <p:sp>
+        <p:nvSpPr>
+          <p:cNvPr id="4" name="TextBox 3"/>
+          <p:cNvSpPr txBox="1"/>
+          <p:nvPr/>
+        </p:nvSpPr>
+        <p:spPr>
+          <a:xfrm>
+            <a:off x="365760" y="164592"/>
+            <a:ext cx="8412480" cy="256032"/>
+          </a:xfrm>
+          <a:prstGeom prst="rect">
+            <a:avLst/>
+          </a:prstGeom>
+          <a:noFill/>
+        </p:spPr>
+        <p:txBody>
+          <a:bodyPr wrap="square">
+            <a:spAutoFit/>
+          </a:bodyPr>
+          <a:lstStyle/>
+          <a:p>
+            <a:pPr algn="l"/>
+            <a:r>
+              <a:rPr sz="1000" b="0">
+                <a:solidFill>
+                  <a:srgbClr val="B0893E"/>
+                </a:solidFill>
+                <a:latin typeface="Calibri"/>
+              </a:rPr>
+              <a:t>EVIDENCE ROOM — AP AGENT OS   ·   Inputs</a:t>
+            </a:r>
+          </a:p>
+        </p:txBody>
+      </p:sp>
+      <p:sp>
+        <p:nvSpPr>
+          <p:cNvPr id="5" name="TextBox 4"/>
+          <p:cNvSpPr txBox="1"/>
+          <p:nvPr/>
+        </p:nvSpPr>
+        <p:spPr>
+          <a:xfrm>
+            <a:off x="365760" y="502920"/>
+            <a:ext cx="8412480" cy="731520"/>
+          </a:xfrm>
+          <a:prstGeom prst="rect">
+            <a:avLst/>
+          </a:prstGeom>
+          <a:noFill/>
+        </p:spPr>
+        <p:txBody>
+          <a:bodyPr wrap="square">
+            <a:spAutoFit/>
+          </a:bodyPr>
+          <a:lstStyle/>
+          <a:p>
+            <a:pPr algn="l"/>
+            <a:r>
+              <a:rPr sz="2600" b="0">
+                <a:solidFill>
+                  <a:srgbClr val="12160F"/>
+                </a:solidFill>
+                <a:latin typeface="Georgia"/>
+              </a:rPr>
+              <a:t>Yellow cells only for a baseline</a:t>
+            </a:r>
+          </a:p>
+        </p:txBody>
+      </p:sp>
+      <p:sp>
+        <p:nvSpPr>
+          <p:cNvPr id="6" name="TextBox 5"/>
+          <p:cNvSpPr txBox="1"/>
+          <p:nvPr/>
+        </p:nvSpPr>
+        <p:spPr>
+          <a:xfrm>
+            <a:off x="365760" y="1371600"/>
+            <a:ext cx="8321040" cy="4937760"/>
+          </a:xfrm>
+          <a:prstGeom prst="rect">
+            <a:avLst/>
+          </a:prstGeom>
+          <a:noFill/>
+        </p:spPr>
+        <p:txBody>
+          <a:bodyPr wrap="square">
+            <a:spAutoFit/>
+          </a:bodyPr>
+          <a:lstStyle/>
+          <a:p>
+            <a:pPr>
+              <a:spcAft>
+                <a:spcPts val="800"/>
+              </a:spcAft>
+            </a:pPr>
+            <a:r>
+              <a:rPr sz="1600">
+                <a:solidFill>
+                  <a:srgbClr val="12160F"/>
+                </a:solidFill>
+                <a:latin typeface="Calibri"/>
+              </a:rPr>
+              <a:t>·  I1 Annual invoice volume.</a:t>
+            </a:r>
+          </a:p>
+          <a:p>
+            <a:pPr>
+              <a:spcAft>
+                <a:spcPts val="800"/>
+              </a:spcAft>
+            </a:pPr>
+            <a:r>
+              <a:rPr sz="1600">
+                <a:solidFill>
+                  <a:srgbClr val="12160F"/>
+                </a:solidFill>
+                <a:latin typeface="Calibri"/>
+              </a:rPr>
+              <a:t>·  I2 Path FTE. I3 Loaded cost. I4 Hours per FTE (must stay visible).</a:t>
+            </a:r>
+          </a:p>
+          <a:p>
+            <a:pPr>
+              <a:spcAft>
+                <a:spcPts val="800"/>
+              </a:spcAft>
+            </a:pPr>
+            <a:r>
+              <a:rPr sz="1600">
+                <a:solidFill>
+                  <a:srgbClr val="12160F"/>
+                </a:solidFill>
+                <a:latin typeface="Calibri"/>
+              </a:rPr>
+              <a:t>·  I5 Manual-touch share. I6 Minutes per manual touch.</a:t>
+            </a:r>
+          </a:p>
+          <a:p>
+            <a:pPr>
+              <a:spcAft>
+                <a:spcPts val="800"/>
+              </a:spcAft>
+            </a:pPr>
+            <a:r>
+              <a:rPr sz="1600">
+                <a:solidFill>
+                  <a:srgbClr val="12160F"/>
+                </a:solidFill>
+                <a:latin typeface="Calibri"/>
+              </a:rPr>
+              <a:t>·  I7 Exception rate. I8 Minutes per exception.</a:t>
+            </a:r>
+          </a:p>
+          <a:p>
+            <a:pPr>
+              <a:spcAft>
+                <a:spcPts val="800"/>
+              </a:spcAft>
+            </a:pPr>
+            <a:r>
+              <a:rPr sz="1600">
+                <a:solidFill>
+                  <a:srgbClr val="12160F"/>
+                </a:solidFill>
+                <a:latin typeface="Calibri"/>
+              </a:rPr>
+              <a:t>·  I12 Tool / model cost and implementation cost.</a:t>
+            </a:r>
+          </a:p>
+          <a:p>
+            <a:pPr>
+              <a:spcAft>
+                <a:spcPts val="800"/>
+              </a:spcAft>
+            </a:pPr>
+            <a:r>
+              <a:rPr sz="1600">
+                <a:solidFill>
+                  <a:srgbClr val="12160F"/>
+                </a:solidFill>
+                <a:latin typeface="Calibri"/>
+              </a:rPr>
+              <a:t>·  I13 Efficiency envelopes — hours released share, not money invented.</a:t>
+            </a:r>
+          </a:p>
+        </p:txBody>
+      </p:sp>
+    </p:spTree>
+  </p:cSld>
+  <p:clrMapOvr>
+    <a:masterClrMapping/>
+  </p:clrMapOvr>
+</p:sld>
+</file>
+
+<file path=ppt/slides/slide4.xml><?xml version="1.0" encoding="utf-8"?>
+<p:sld xmlns:a="http://schemas.openxmlformats.org/drawingml/2006/main" xmlns:p="http://schemas.openxmlformats.org/presentationml/2006/main" xmlns:r="http://schemas.openxmlformats.org/officeDocument/2006/relationships">
+  <p:cSld>
+    <p:spTree>
+      <p:nvGrpSpPr>
+        <p:cNvPr id="1" name=""/>
+        <p:cNvGrpSpPr/>
+        <p:nvPr/>
+      </p:nvGrpSpPr>
+      <p:grpSpPr/>
+      <p:sp>
+        <p:nvSpPr>
+          <p:cNvPr id="2" name="Rectangle 1"/>
+          <p:cNvSpPr/>
+          <p:nvPr/>
+        </p:nvSpPr>
+        <p:spPr>
+          <a:xfrm>
+            <a:off x="0" y="0"/>
+            <a:ext cx="9144000" cy="6858000"/>
+          </a:xfrm>
+          <a:prstGeom prst="rect">
+            <a:avLst/>
+          </a:prstGeom>
+          <a:solidFill>
+            <a:srgbClr val="F3EEE4"/>
+          </a:solidFill>
+          <a:ln>
+            <a:noFill/>
+          </a:ln>
+        </p:spPr>
+        <p:style>
+          <a:lnRef idx="1">
+            <a:schemeClr val="accent1"/>
+          </a:lnRef>
+          <a:fillRef idx="3">
+            <a:schemeClr val="accent1"/>
+          </a:fillRef>
+          <a:effectRef idx="2">
+            <a:schemeClr val="accent1"/>
+          </a:effectRef>
+          <a:fontRef idx="minor">
+            <a:schemeClr val="lt1"/>
+          </a:fontRef>
+        </p:style>
+        <p:txBody>
+          <a:bodyPr rtlCol="0" anchor="ctr"/>
+          <a:lstStyle/>
+          <a:p>
+            <a:pPr algn="ctr"/>
+          </a:p>
+        </p:txBody>
+      </p:sp>
+      <p:sp>
+        <p:nvSpPr>
+          <p:cNvPr id="3" name="Rectangle 2"/>
+          <p:cNvSpPr/>
+          <p:nvPr/>
+        </p:nvSpPr>
+        <p:spPr>
+          <a:xfrm>
+            <a:off x="0" y="0"/>
+            <a:ext cx="73152" cy="6858000"/>
+          </a:xfrm>
+          <a:prstGeom prst="rect">
+            <a:avLst/>
+          </a:prstGeom>
+          <a:solidFill>
+            <a:srgbClr val="B0893E"/>
+          </a:solidFill>
+          <a:ln>
+            <a:noFill/>
+          </a:ln>
+        </p:spPr>
+        <p:style>
+          <a:lnRef idx="1">
+            <a:schemeClr val="accent1"/>
+          </a:lnRef>
+          <a:fillRef idx="3">
+            <a:schemeClr val="accent1"/>
+          </a:fillRef>
+          <a:effectRef idx="2">
+            <a:schemeClr val="accent1"/>
+          </a:effectRef>
+          <a:fontRef idx="minor">
+            <a:schemeClr val="lt1"/>
+          </a:fontRef>
+        </p:style>
+        <p:txBody>
+          <a:bodyPr rtlCol="0" anchor="ctr"/>
+          <a:lstStyle/>
+          <a:p>
+            <a:pPr algn="ctr"/>
+          </a:p>
+        </p:txBody>
+      </p:sp>
+      <p:sp>
+        <p:nvSpPr>
+          <p:cNvPr id="4" name="TextBox 3"/>
+          <p:cNvSpPr txBox="1"/>
+          <p:nvPr/>
+        </p:nvSpPr>
+        <p:spPr>
+          <a:xfrm>
+            <a:off x="365760" y="164592"/>
+            <a:ext cx="8412480" cy="256032"/>
+          </a:xfrm>
+          <a:prstGeom prst="rect">
+            <a:avLst/>
+          </a:prstGeom>
+          <a:noFill/>
+        </p:spPr>
+        <p:txBody>
+          <a:bodyPr wrap="square">
+            <a:spAutoFit/>
+          </a:bodyPr>
+          <a:lstStyle/>
+          <a:p>
+            <a:pPr algn="l"/>
+            <a:r>
+              <a:rPr sz="1000" b="0">
+                <a:solidFill>
+                  <a:srgbClr val="B0893E"/>
+                </a:solidFill>
+                <a:latin typeface="Calibri"/>
+              </a:rPr>
+              <a:t>EVIDENCE ROOM — AP AGENT OS   ·   Refusals</a:t>
+            </a:r>
+          </a:p>
+        </p:txBody>
+      </p:sp>
+      <p:sp>
+        <p:nvSpPr>
+          <p:cNvPr id="5" name="TextBox 4"/>
+          <p:cNvSpPr txBox="1"/>
+          <p:nvPr/>
+        </p:nvSpPr>
+        <p:spPr>
+          <a:xfrm>
+            <a:off x="365760" y="502920"/>
+            <a:ext cx="8412480" cy="548640"/>
+          </a:xfrm>
+          <a:prstGeom prst="rect">
+            <a:avLst/>
+          </a:prstGeom>
+          <a:noFill/>
+        </p:spPr>
+        <p:txBody>
+          <a:bodyPr wrap="square">
+            <a:spAutoFit/>
+          </a:bodyPr>
+          <a:lstStyle/>
+          <a:p>
+            <a:pPr algn="l"/>
+            <a:r>
+              <a:rPr sz="2400" b="0">
+                <a:solidFill>
+                  <a:srgbClr val="12160F"/>
+                </a:solidFill>
+                <a:latin typeface="Georgia"/>
+              </a:rPr>
+              <a:t>What the model will not do</a:t>
+            </a:r>
+          </a:p>
+        </p:txBody>
+      </p:sp>
+      <p:sp>
+        <p:nvSpPr>
+          <p:cNvPr id="6" name="Rectangle 5"/>
+          <p:cNvSpPr/>
+          <p:nvPr/>
+        </p:nvSpPr>
+        <p:spPr>
+          <a:xfrm>
+            <a:off x="365760" y="1234440"/>
+            <a:ext cx="4023360" cy="5029200"/>
+          </a:xfrm>
+          <a:prstGeom prst="rect">
+            <a:avLst/>
+          </a:prstGeom>
+          <a:solidFill>
+            <a:srgbClr val="FAF8F3"/>
+          </a:solidFill>
+          <a:ln>
+            <a:noFill/>
+          </a:ln>
+        </p:spPr>
+        <p:style>
+          <a:lnRef idx="1">
+            <a:schemeClr val="accent1"/>
+          </a:lnRef>
+          <a:fillRef idx="3">
+            <a:schemeClr val="accent1"/>
+          </a:fillRef>
+          <a:effectRef idx="2">
+            <a:schemeClr val="accent1"/>
+          </a:effectRef>
+          <a:fontRef idx="minor">
+            <a:schemeClr val="lt1"/>
+          </a:fontRef>
+        </p:style>
+        <p:txBody>
+          <a:bodyPr rtlCol="0" anchor="ctr"/>
+          <a:lstStyle/>
+          <a:p>
+            <a:pPr algn="ctr"/>
+          </a:p>
+        </p:txBody>
+      </p:sp>
+      <p:sp>
+        <p:nvSpPr>
+          <p:cNvPr id="7" name="Rectangle 6"/>
+          <p:cNvSpPr/>
+          <p:nvPr/>
+        </p:nvSpPr>
+        <p:spPr>
+          <a:xfrm>
+            <a:off x="4754880" y="1234440"/>
+            <a:ext cx="4023360" cy="5029200"/>
+          </a:xfrm>
+          <a:prstGeom prst="rect">
+            <a:avLst/>
+          </a:prstGeom>
+          <a:solidFill>
+            <a:srgbClr val="FAF8F3"/>
+          </a:solidFill>
+          <a:ln>
+            <a:noFill/>
+          </a:ln>
+        </p:spPr>
+        <p:style>
+          <a:lnRef idx="1">
+            <a:schemeClr val="accent1"/>
+          </a:lnRef>
+          <a:fillRef idx="3">
+            <a:schemeClr val="accent1"/>
+          </a:fillRef>
+          <a:effectRef idx="2">
+            <a:schemeClr val="accent1"/>
+          </a:effectRef>
+          <a:fontRef idx="minor">
+            <a:schemeClr val="lt1"/>
+          </a:fontRef>
+        </p:style>
+        <p:txBody>
+          <a:bodyPr rtlCol="0" anchor="ctr"/>
+          <a:lstStyle/>
+          <a:p>
+            <a:pPr algn="ctr"/>
+          </a:p>
+        </p:txBody>
+      </p:sp>
+      <p:sp>
+        <p:nvSpPr>
+          <p:cNvPr id="8" name="TextBox 7"/>
+          <p:cNvSpPr txBox="1"/>
+          <p:nvPr/>
+        </p:nvSpPr>
+        <p:spPr>
+          <a:xfrm>
+            <a:off x="502920" y="1371600"/>
+            <a:ext cx="3749039" cy="365760"/>
+          </a:xfrm>
+          <a:prstGeom prst="rect">
+            <a:avLst/>
+          </a:prstGeom>
+          <a:noFill/>
+        </p:spPr>
+        <p:txBody>
+          <a:bodyPr wrap="square">
+            <a:spAutoFit/>
+          </a:bodyPr>
+          <a:lstStyle/>
+          <a:p>
+            <a:pPr algn="l"/>
+            <a:r>
+              <a:rPr sz="1400" b="1">
+                <a:solidFill>
+                  <a:srgbClr val="B0893E"/>
+                </a:solidFill>
+                <a:latin typeface="Calibri"/>
+              </a:rPr>
+              <a:t>Forced to zero</a:t>
+            </a:r>
+          </a:p>
+        </p:txBody>
+      </p:sp>
+      <p:sp>
+        <p:nvSpPr>
+          <p:cNvPr id="9" name="TextBox 8"/>
+          <p:cNvSpPr txBox="1"/>
+          <p:nvPr/>
+        </p:nvSpPr>
+        <p:spPr>
+          <a:xfrm>
+            <a:off x="502920" y="1828800"/>
+            <a:ext cx="3749039" cy="4206240"/>
+          </a:xfrm>
+          <a:prstGeom prst="rect">
+            <a:avLst/>
+          </a:prstGeom>
+          <a:noFill/>
+        </p:spPr>
+        <p:txBody>
+          <a:bodyPr wrap="square">
+            <a:spAutoFit/>
+          </a:bodyPr>
+          <a:lstStyle/>
+          <a:p>
+            <a:pPr>
+              <a:spcAft>
+                <a:spcPts val="800"/>
+              </a:spcAft>
+            </a:pPr>
+            <a:r>
+              <a:rPr sz="1400">
+                <a:solidFill>
+                  <a:srgbClr val="12160F"/>
+                </a:solidFill>
+                <a:latin typeface="Calibri"/>
+              </a:rPr>
+              <a:t>·  Duplicate-suspect savings</a:t>
+            </a:r>
+          </a:p>
+          <a:p>
+            <a:pPr>
+              <a:spcAft>
+                <a:spcPts val="800"/>
+              </a:spcAft>
+            </a:pPr>
+            <a:r>
+              <a:rPr sz="1400">
+                <a:solidFill>
+                  <a:srgbClr val="12160F"/>
+                </a:solidFill>
+                <a:latin typeface="Calibri"/>
+              </a:rPr>
+              <a:t>·  Blank late-pay or early-pay credits</a:t>
+            </a:r>
+          </a:p>
+          <a:p>
+            <a:pPr>
+              <a:spcAft>
+                <a:spcPts val="800"/>
+              </a:spcAft>
+            </a:pPr>
+            <a:r>
+              <a:rPr sz="1400">
+                <a:solidFill>
+                  <a:srgbClr val="12160F"/>
+                </a:solidFill>
+                <a:latin typeface="Calibri"/>
+              </a:rPr>
+              <a:t>·  Vendor benchmark as a target</a:t>
+            </a:r>
+          </a:p>
+          <a:p>
+            <a:pPr>
+              <a:spcAft>
+                <a:spcPts val="800"/>
+              </a:spcAft>
+            </a:pPr>
+            <a:r>
+              <a:rPr sz="1400">
+                <a:solidFill>
+                  <a:srgbClr val="12160F"/>
+                </a:solidFill>
+                <a:latin typeface="Calibri"/>
+              </a:rPr>
+              <a:t>·  A single composite “AI score”</a:t>
+            </a:r>
+          </a:p>
+        </p:txBody>
+      </p:sp>
+      <p:sp>
+        <p:nvSpPr>
+          <p:cNvPr id="10" name="TextBox 9"/>
+          <p:cNvSpPr txBox="1"/>
+          <p:nvPr/>
+        </p:nvSpPr>
+        <p:spPr>
+          <a:xfrm>
+            <a:off x="4892040" y="1371600"/>
+            <a:ext cx="3749039" cy="365760"/>
+          </a:xfrm>
+          <a:prstGeom prst="rect">
+            <a:avLst/>
+          </a:prstGeom>
+          <a:noFill/>
+        </p:spPr>
+        <p:txBody>
+          <a:bodyPr wrap="square">
+            <a:spAutoFit/>
+          </a:bodyPr>
+          <a:lstStyle/>
+          <a:p>
+            <a:pPr algn="l"/>
+            <a:r>
+              <a:rPr sz="1400" b="1">
+                <a:solidFill>
+                  <a:srgbClr val="B0893E"/>
+                </a:solidFill>
+                <a:latin typeface="Calibri"/>
+              </a:rPr>
+              <a:t>Human only</a:t>
+            </a:r>
+          </a:p>
+        </p:txBody>
+      </p:sp>
+      <p:sp>
+        <p:nvSpPr>
+          <p:cNvPr id="11" name="TextBox 10"/>
+          <p:cNvSpPr txBox="1"/>
+          <p:nvPr/>
+        </p:nvSpPr>
+        <p:spPr>
+          <a:xfrm>
+            <a:off x="4892040" y="1828800"/>
+            <a:ext cx="3749039" cy="4206240"/>
+          </a:xfrm>
+          <a:prstGeom prst="rect">
+            <a:avLst/>
+          </a:prstGeom>
+          <a:noFill/>
+        </p:spPr>
+        <p:txBody>
+          <a:bodyPr wrap="square">
+            <a:spAutoFit/>
+          </a:bodyPr>
+          <a:lstStyle/>
+          <a:p>
+            <a:pPr>
+              <a:spcAft>
+                <a:spcPts val="800"/>
+              </a:spcAft>
+            </a:pPr>
+            <a:r>
+              <a:rPr sz="1400">
+                <a:solidFill>
+                  <a:srgbClr val="12160F"/>
+                </a:solidFill>
+                <a:latin typeface="Calibri"/>
+              </a:rPr>
+              <a:t>·  Payment release</a:t>
+            </a:r>
+          </a:p>
+          <a:p>
+            <a:pPr>
+              <a:spcAft>
+                <a:spcPts val="800"/>
+              </a:spcAft>
+            </a:pPr>
+            <a:r>
+              <a:rPr sz="1400">
+                <a:solidFill>
+                  <a:srgbClr val="12160F"/>
+                </a:solidFill>
+                <a:latin typeface="Calibri"/>
+              </a:rPr>
+              <a:t>·  Attestation of savings</a:t>
+            </a:r>
+          </a:p>
+          <a:p>
+            <a:pPr>
+              <a:spcAft>
+                <a:spcPts val="800"/>
+              </a:spcAft>
+            </a:pPr>
+            <a:r>
+              <a:rPr sz="1400">
+                <a:solidFill>
+                  <a:srgbClr val="12160F"/>
+                </a:solidFill>
+                <a:latin typeface="Calibri"/>
+              </a:rPr>
+              <a:t>·  Choice of envelope to show a board</a:t>
+            </a:r>
+          </a:p>
+          <a:p>
+            <a:pPr>
+              <a:spcAft>
+                <a:spcPts val="800"/>
+              </a:spcAft>
+            </a:pPr>
+            <a:r>
+              <a:rPr sz="1400">
+                <a:solidFill>
+                  <a:srgbClr val="12160F"/>
+                </a:solidFill>
+                <a:latin typeface="Calibri"/>
+              </a:rPr>
+              <a:t>·  Whether to proceed at all</a:t>
+            </a:r>
+          </a:p>
+        </p:txBody>
+      </p:sp>
+    </p:spTree>
+  </p:cSld>
+  <p:clrMapOvr>
+    <a:masterClrMapping/>
+  </p:clrMapOvr>
+</p:sld>
+</file>
+
+<file path=ppt/slides/slide5.xml><?xml version="1.0" encoding="utf-8"?>
+<p:sld xmlns:a="http://schemas.openxmlformats.org/drawingml/2006/main" xmlns:p="http://schemas.openxmlformats.org/presentationml/2006/main" xmlns:r="http://schemas.openxmlformats.org/officeDocument/2006/relationships">
+  <p:cSld>
+    <p:spTree>
+      <p:nvGrpSpPr>
+        <p:cNvPr id="1" name=""/>
+        <p:cNvGrpSpPr/>
+        <p:nvPr/>
+      </p:nvGrpSpPr>
+      <p:grpSpPr/>
+      <p:sp>
+        <p:nvSpPr>
+          <p:cNvPr id="2" name="Rectangle 1"/>
+          <p:cNvSpPr/>
+          <p:nvPr/>
+        </p:nvSpPr>
+        <p:spPr>
+          <a:xfrm>
+            <a:off x="0" y="0"/>
+            <a:ext cx="9144000" cy="6858000"/>
+          </a:xfrm>
+          <a:prstGeom prst="rect">
+            <a:avLst/>
+          </a:prstGeom>
+          <a:solidFill>
+            <a:srgbClr val="F3EEE4"/>
+          </a:solidFill>
+          <a:ln>
+            <a:noFill/>
+          </a:ln>
+        </p:spPr>
+        <p:style>
+          <a:lnRef idx="1">
+            <a:schemeClr val="accent1"/>
+          </a:lnRef>
+          <a:fillRef idx="3">
+            <a:schemeClr val="accent1"/>
+          </a:fillRef>
+          <a:effectRef idx="2">
+            <a:schemeClr val="accent1"/>
+          </a:effectRef>
+          <a:fontRef idx="minor">
+            <a:schemeClr val="lt1"/>
+          </a:fontRef>
+        </p:style>
+        <p:txBody>
+          <a:bodyPr rtlCol="0" anchor="ctr"/>
+          <a:lstStyle/>
+          <a:p>
+            <a:pPr algn="ctr"/>
+          </a:p>
+        </p:txBody>
+      </p:sp>
+      <p:sp>
+        <p:nvSpPr>
+          <p:cNvPr id="3" name="Rectangle 2"/>
+          <p:cNvSpPr/>
+          <p:nvPr/>
+        </p:nvSpPr>
+        <p:spPr>
+          <a:xfrm>
+            <a:off x="0" y="0"/>
+            <a:ext cx="73152" cy="6858000"/>
+          </a:xfrm>
+          <a:prstGeom prst="rect">
+            <a:avLst/>
+          </a:prstGeom>
+          <a:solidFill>
+            <a:srgbClr val="B0893E"/>
+          </a:solidFill>
+          <a:ln>
+            <a:noFill/>
+          </a:ln>
+        </p:spPr>
+        <p:style>
+          <a:lnRef idx="1">
+            <a:schemeClr val="accent1"/>
+          </a:lnRef>
+          <a:fillRef idx="3">
+            <a:schemeClr val="accent1"/>
+          </a:fillRef>
+          <a:effectRef idx="2">
+            <a:schemeClr val="accent1"/>
+          </a:effectRef>
+          <a:fontRef idx="minor">
+            <a:schemeClr val="lt1"/>
+          </a:fontRef>
+        </p:style>
+        <p:txBody>
+          <a:bodyPr rtlCol="0" anchor="ctr"/>
+          <a:lstStyle/>
+          <a:p>
+            <a:pPr algn="ctr"/>
+          </a:p>
+        </p:txBody>
+      </p:sp>
+      <p:sp>
+        <p:nvSpPr>
+          <p:cNvPr id="4" name="TextBox 3"/>
+          <p:cNvSpPr txBox="1"/>
+          <p:nvPr/>
+        </p:nvSpPr>
+        <p:spPr>
+          <a:xfrm>
+            <a:off x="365760" y="164592"/>
+            <a:ext cx="8412480" cy="256032"/>
+          </a:xfrm>
+          <a:prstGeom prst="rect">
+            <a:avLst/>
+          </a:prstGeom>
+          <a:noFill/>
+        </p:spPr>
+        <p:txBody>
+          <a:bodyPr wrap="square">
+            <a:spAutoFit/>
+          </a:bodyPr>
+          <a:lstStyle/>
+          <a:p>
+            <a:pPr algn="l"/>
+            <a:r>
+              <a:rPr sz="1000" b="0">
+                <a:solidFill>
+                  <a:srgbClr val="B0893E"/>
+                </a:solidFill>
+                <a:latin typeface="Calibri"/>
+              </a:rPr>
+              <a:t>EVIDENCE ROOM — AP AGENT OS   ·   Families</a:t>
+            </a:r>
+          </a:p>
+        </p:txBody>
+      </p:sp>
+      <p:sp>
+        <p:nvSpPr>
+          <p:cNvPr id="5" name="TextBox 4"/>
+          <p:cNvSpPr txBox="1"/>
+          <p:nvPr/>
+        </p:nvSpPr>
+        <p:spPr>
+          <a:xfrm>
+            <a:off x="365760" y="502920"/>
+            <a:ext cx="8412480" cy="731520"/>
+          </a:xfrm>
+          <a:prstGeom prst="rect">
+            <a:avLst/>
+          </a:prstGeom>
+          <a:noFill/>
+        </p:spPr>
+        <p:txBody>
+          <a:bodyPr wrap="square">
+            <a:spAutoFit/>
+          </a:bodyPr>
+          <a:lstStyle/>
+          <a:p>
+            <a:pPr algn="l"/>
+            <a:r>
+              <a:rPr sz="2600" b="0">
+                <a:solidFill>
+                  <a:srgbClr val="12160F"/>
+                </a:solidFill>
+                <a:latin typeface="Georgia"/>
+              </a:rPr>
+              <a:t>Do not average these into one number</a:t>
+            </a:r>
+          </a:p>
+        </p:txBody>
+      </p:sp>
+      <p:sp>
+        <p:nvSpPr>
+          <p:cNvPr id="6" name="TextBox 5"/>
+          <p:cNvSpPr txBox="1"/>
+          <p:nvPr/>
+        </p:nvSpPr>
+        <p:spPr>
+          <a:xfrm>
+            <a:off x="365760" y="1371600"/>
+            <a:ext cx="8321040" cy="4937760"/>
+          </a:xfrm>
+          <a:prstGeom prst="rect">
+            <a:avLst/>
+          </a:prstGeom>
+          <a:noFill/>
+        </p:spPr>
+        <p:txBody>
+          <a:bodyPr wrap="square">
+            <a:spAutoFit/>
+          </a:bodyPr>
+          <a:lstStyle/>
+          <a:p>
+            <a:pPr>
+              <a:spcAft>
+                <a:spcPts val="800"/>
+              </a:spcAft>
+            </a:pPr>
+            <a:r>
+              <a:rPr sz="1600">
+                <a:solidFill>
+                  <a:srgbClr val="12160F"/>
+                </a:solidFill>
+                <a:latin typeface="Calibri"/>
+              </a:rPr>
+              <a:t>·  Activity — volume context only.</a:t>
+            </a:r>
+          </a:p>
+          <a:p>
+            <a:pPr>
+              <a:spcAft>
+                <a:spcPts val="800"/>
+              </a:spcAft>
+            </a:pPr>
+            <a:r>
+              <a:rPr sz="1600">
+                <a:solidFill>
+                  <a:srgbClr val="12160F"/>
+                </a:solidFill>
+                <a:latin typeface="Calibri"/>
+              </a:rPr>
+              <a:t>·  Operational — accuracy, ageing, intervention. May veto expansion.</a:t>
+            </a:r>
+          </a:p>
+          <a:p>
+            <a:pPr>
+              <a:spcAft>
+                <a:spcPts val="800"/>
+              </a:spcAft>
+            </a:pPr>
+            <a:r>
+              <a:rPr sz="1600">
+                <a:solidFill>
+                  <a:srgbClr val="12160F"/>
+                </a:solidFill>
+                <a:latin typeface="Calibri"/>
+              </a:rPr>
+              <a:t>·  Financial — cost and validated money movement. Never overrides risk-control.</a:t>
+            </a:r>
+          </a:p>
+          <a:p>
+            <a:pPr>
+              <a:spcAft>
+                <a:spcPts val="800"/>
+              </a:spcAft>
+            </a:pPr>
+            <a:r>
+              <a:rPr sz="1600">
+                <a:solidFill>
+                  <a:srgbClr val="12160F"/>
+                </a:solidFill>
+                <a:latin typeface="Calibri"/>
+              </a:rPr>
+              <a:t>·  Risk-control — breaches, reconstructability. May veto expansion.</a:t>
+            </a:r>
+          </a:p>
+        </p:txBody>
+      </p:sp>
+    </p:spTree>
+  </p:cSld>
+  <p:clrMapOvr>
+    <a:masterClrMapping/>
+  </p:clrMapOvr>
+</p:sld>
+</file>
+
+<file path=ppt/slides/slide6.xml><?xml version="1.0" encoding="utf-8"?>
+<p:sld xmlns:a="http://schemas.openxmlformats.org/drawingml/2006/main" xmlns:p="http://schemas.openxmlformats.org/presentationml/2006/main" xmlns:r="http://schemas.openxmlformats.org/officeDocument/2006/relationships">
+  <p:cSld>
+    <p:spTree>
+      <p:nvGrpSpPr>
+        <p:cNvPr id="1" name=""/>
+        <p:cNvGrpSpPr/>
+        <p:nvPr/>
+      </p:nvGrpSpPr>
+      <p:grpSpPr/>
+      <p:sp>
+        <p:nvSpPr>
+          <p:cNvPr id="2" name="Rectangle 1"/>
+          <p:cNvSpPr/>
+          <p:nvPr/>
+        </p:nvSpPr>
+        <p:spPr>
+          <a:xfrm>
+            <a:off x="0" y="0"/>
+            <a:ext cx="9144000" cy="6858000"/>
+          </a:xfrm>
+          <a:prstGeom prst="rect">
+            <a:avLst/>
+          </a:prstGeom>
+          <a:solidFill>
+            <a:srgbClr val="F3EEE4"/>
+          </a:solidFill>
+          <a:ln>
+            <a:noFill/>
+          </a:ln>
+        </p:spPr>
+        <p:style>
+          <a:lnRef idx="1">
+            <a:schemeClr val="accent1"/>
+          </a:lnRef>
+          <a:fillRef idx="3">
+            <a:schemeClr val="accent1"/>
+          </a:fillRef>
+          <a:effectRef idx="2">
+            <a:schemeClr val="accent1"/>
+          </a:effectRef>
+          <a:fontRef idx="minor">
+            <a:schemeClr val="lt1"/>
+          </a:fontRef>
+        </p:style>
+        <p:txBody>
+          <a:bodyPr rtlCol="0" anchor="ctr"/>
+          <a:lstStyle/>
+          <a:p>
+            <a:pPr algn="ctr"/>
+          </a:p>
+        </p:txBody>
+      </p:sp>
+      <p:sp>
+        <p:nvSpPr>
+          <p:cNvPr id="3" name="Rectangle 2"/>
+          <p:cNvSpPr/>
+          <p:nvPr/>
+        </p:nvSpPr>
+        <p:spPr>
+          <a:xfrm>
+            <a:off x="0" y="0"/>
+            <a:ext cx="73152" cy="6858000"/>
+          </a:xfrm>
+          <a:prstGeom prst="rect">
+            <a:avLst/>
+          </a:prstGeom>
+          <a:solidFill>
+            <a:srgbClr val="B0893E"/>
+          </a:solidFill>
+          <a:ln>
+            <a:noFill/>
+          </a:ln>
+        </p:spPr>
+        <p:style>
+          <a:lnRef idx="1">
+            <a:schemeClr val="accent1"/>
+          </a:lnRef>
+          <a:fillRef idx="3">
+            <a:schemeClr val="accent1"/>
+          </a:fillRef>
+          <a:effectRef idx="2">
+            <a:schemeClr val="accent1"/>
+          </a:effectRef>
+          <a:fontRef idx="minor">
+            <a:schemeClr val="lt1"/>
+          </a:fontRef>
+        </p:style>
+        <p:txBody>
+          <a:bodyPr rtlCol="0" anchor="ctr"/>
+          <a:lstStyle/>
+          <a:p>
+            <a:pPr algn="ctr"/>
+          </a:p>
+        </p:txBody>
+      </p:sp>
+      <p:sp>
+        <p:nvSpPr>
+          <p:cNvPr id="4" name="TextBox 3"/>
+          <p:cNvSpPr txBox="1"/>
+          <p:nvPr/>
+        </p:nvSpPr>
+        <p:spPr>
+          <a:xfrm>
+            <a:off x="365760" y="164592"/>
+            <a:ext cx="8412480" cy="256032"/>
+          </a:xfrm>
+          <a:prstGeom prst="rect">
+            <a:avLst/>
+          </a:prstGeom>
+          <a:noFill/>
+        </p:spPr>
+        <p:txBody>
+          <a:bodyPr wrap="square">
+            <a:spAutoFit/>
+          </a:bodyPr>
+          <a:lstStyle/>
+          <a:p>
+            <a:pPr algn="l"/>
+            <a:r>
+              <a:rPr sz="1000" b="0">
+                <a:solidFill>
+                  <a:srgbClr val="B0893E"/>
+                </a:solidFill>
+                <a:latin typeface="Calibri"/>
+              </a:rPr>
+              <a:t>EVIDENCE ROOM — AP AGENT OS   ·   Northline</a:t>
+            </a:r>
+          </a:p>
+        </p:txBody>
+      </p:sp>
+      <p:sp>
+        <p:nvSpPr>
+          <p:cNvPr id="5" name="TextBox 4"/>
+          <p:cNvSpPr txBox="1"/>
+          <p:nvPr/>
+        </p:nvSpPr>
+        <p:spPr>
+          <a:xfrm>
+            <a:off x="365760" y="502920"/>
+            <a:ext cx="8412480" cy="731520"/>
+          </a:xfrm>
+          <a:prstGeom prst="rect">
+            <a:avLst/>
+          </a:prstGeom>
+          <a:noFill/>
+        </p:spPr>
+        <p:txBody>
+          <a:bodyPr wrap="square">
+            <a:spAutoFit/>
+          </a:bodyPr>
+          <a:lstStyle/>
+          <a:p>
+            <a:pPr algn="l"/>
+            <a:r>
+              <a:rPr sz="2600" b="0">
+                <a:solidFill>
+                  <a:srgbClr val="12160F"/>
+                </a:solidFill>
+                <a:latin typeface="Georgia"/>
+              </a:rPr>
+              <a:t>Fictional illustration only</a:t>
+            </a:r>
+          </a:p>
+        </p:txBody>
+      </p:sp>
+      <p:sp>
+        <p:nvSpPr>
+          <p:cNvPr id="6" name="TextBox 5"/>
+          <p:cNvSpPr txBox="1"/>
+          <p:nvPr/>
+        </p:nvSpPr>
+        <p:spPr>
+          <a:xfrm>
+            <a:off x="365760" y="1371600"/>
+            <a:ext cx="8321040" cy="4937760"/>
+          </a:xfrm>
+          <a:prstGeom prst="rect">
+            <a:avLst/>
+          </a:prstGeom>
+          <a:noFill/>
+        </p:spPr>
+        <p:txBody>
+          <a:bodyPr wrap="square">
+            <a:spAutoFit/>
+          </a:bodyPr>
+          <a:lstStyle/>
+          <a:p>
+            <a:pPr>
+              <a:spcAft>
+                <a:spcPts val="800"/>
+              </a:spcAft>
+            </a:pPr>
+            <a:r>
+              <a:rPr sz="1600">
+                <a:solidFill>
+                  <a:srgbClr val="12160F"/>
+                </a:solidFill>
+                <a:latin typeface="Calibri"/>
+              </a:rPr>
+              <a:t>·  180,000 invoices / year. 14 path FTE. $85,000 loaded.</a:t>
+            </a:r>
+          </a:p>
+          <a:p>
+            <a:pPr>
+              <a:spcAft>
+                <a:spcPts val="800"/>
+              </a:spcAft>
+            </a:pPr>
+            <a:r>
+              <a:rPr sz="1600">
+                <a:solidFill>
+                  <a:srgbClr val="12160F"/>
+                </a:solidFill>
+                <a:latin typeface="Calibri"/>
+              </a:rPr>
+              <a:t>·  Used so the sheets are not empty.</a:t>
+            </a:r>
+          </a:p>
+          <a:p>
+            <a:pPr>
+              <a:spcAft>
+                <a:spcPts val="800"/>
+              </a:spcAft>
+            </a:pPr>
+            <a:r>
+              <a:rPr sz="1600">
+                <a:solidFill>
+                  <a:srgbClr val="12160F"/>
+                </a:solidFill>
+                <a:latin typeface="Calibri"/>
+              </a:rPr>
+              <a:t>·  Replace every input before any internal circulation that looks like a forecast.</a:t>
+            </a:r>
+          </a:p>
+          <a:p>
+            <a:pPr>
+              <a:spcAft>
+                <a:spcPts val="800"/>
+              </a:spcAft>
+            </a:pPr>
+            <a:r>
+              <a:rPr sz="1600">
+                <a:solidFill>
+                  <a:srgbClr val="12160F"/>
+                </a:solidFill>
+                <a:latin typeface="Calibri"/>
+              </a:rPr>
+              <a:t>·  Label Northline fictional in the first mention of a figure.</a:t>
+            </a:r>
+          </a:p>
+        </p:txBody>
+      </p:sp>
+    </p:spTree>
+  </p:cSld>
+  <p:clrMapOvr>
+    <a:masterClrMapping/>
+  </p:clrMapOvr>
+</p:sld>
+</file>
+
+<file path=ppt/slides/slide7.xml><?xml version="1.0" encoding="utf-8"?>
+<p:sld xmlns:a="http://schemas.openxmlformats.org/drawingml/2006/main" xmlns:p="http://schemas.openxmlformats.org/presentationml/2006/main" xmlns:r="http://schemas.openxmlformats.org/officeDocument/2006/relationships">
+  <p:cSld>
+    <p:spTree>
+      <p:nvGrpSpPr>
+        <p:cNvPr id="1" name=""/>
+        <p:cNvGrpSpPr/>
+        <p:nvPr/>
+      </p:nvGrpSpPr>
+      <p:grpSpPr/>
+      <p:sp>
+        <p:nvSpPr>
+          <p:cNvPr id="2" name="Rectangle 1"/>
+          <p:cNvSpPr/>
+          <p:nvPr/>
+        </p:nvSpPr>
+        <p:spPr>
+          <a:xfrm>
+            <a:off x="0" y="0"/>
+            <a:ext cx="9144000" cy="6858000"/>
+          </a:xfrm>
+          <a:prstGeom prst="rect">
+            <a:avLst/>
+          </a:prstGeom>
+          <a:solidFill>
+            <a:srgbClr val="F3EEE4"/>
+          </a:solidFill>
+          <a:ln>
+            <a:noFill/>
+          </a:ln>
+        </p:spPr>
+        <p:style>
+          <a:lnRef idx="1">
+            <a:schemeClr val="accent1"/>
+          </a:lnRef>
+          <a:fillRef idx="3">
+            <a:schemeClr val="accent1"/>
+          </a:fillRef>
+          <a:effectRef idx="2">
+            <a:schemeClr val="accent1"/>
+          </a:effectRef>
+          <a:fontRef idx="minor">
+            <a:schemeClr val="lt1"/>
+          </a:fontRef>
+        </p:style>
+        <p:txBody>
+          <a:bodyPr rtlCol="0" anchor="ctr"/>
+          <a:lstStyle/>
+          <a:p>
+            <a:pPr algn="ctr"/>
+          </a:p>
+        </p:txBody>
+      </p:sp>
+      <p:sp>
+        <p:nvSpPr>
+          <p:cNvPr id="3" name="Rectangle 2"/>
+          <p:cNvSpPr/>
+          <p:nvPr/>
+        </p:nvSpPr>
+        <p:spPr>
+          <a:xfrm>
+            <a:off x="0" y="0"/>
+            <a:ext cx="73152" cy="6858000"/>
+          </a:xfrm>
+          <a:prstGeom prst="rect">
+            <a:avLst/>
+          </a:prstGeom>
+          <a:solidFill>
+            <a:srgbClr val="B0893E"/>
+          </a:solidFill>
+          <a:ln>
+            <a:noFill/>
+          </a:ln>
+        </p:spPr>
+        <p:style>
+          <a:lnRef idx="1">
+            <a:schemeClr val="accent1"/>
+          </a:lnRef>
+          <a:fillRef idx="3">
+            <a:schemeClr val="accent1"/>
+          </a:fillRef>
+          <a:effectRef idx="2">
+            <a:schemeClr val="accent1"/>
+          </a:effectRef>
+          <a:fontRef idx="minor">
+            <a:schemeClr val="lt1"/>
+          </a:fontRef>
+        </p:style>
+        <p:txBody>
+          <a:bodyPr rtlCol="0" anchor="ctr"/>
+          <a:lstStyle/>
+          <a:p>
+            <a:pPr algn="ctr"/>
+          </a:p>
+        </p:txBody>
+      </p:sp>
+      <p:sp>
+        <p:nvSpPr>
+          <p:cNvPr id="4" name="TextBox 3"/>
+          <p:cNvSpPr txBox="1"/>
+          <p:nvPr/>
+        </p:nvSpPr>
+        <p:spPr>
+          <a:xfrm>
+            <a:off x="365760" y="164592"/>
+            <a:ext cx="8412480" cy="256032"/>
+          </a:xfrm>
+          <a:prstGeom prst="rect">
+            <a:avLst/>
+          </a:prstGeom>
+          <a:noFill/>
+        </p:spPr>
+        <p:txBody>
+          <a:bodyPr wrap="square">
+            <a:spAutoFit/>
+          </a:bodyPr>
+          <a:lstStyle/>
+          <a:p>
+            <a:pPr algn="l"/>
+            <a:r>
+              <a:rPr sz="1000" b="0">
+                <a:solidFill>
+                  <a:srgbClr val="B0893E"/>
+                </a:solidFill>
+                <a:latin typeface="Calibri"/>
+              </a:rPr>
+              <a:t>EVIDENCE ROOM — AP AGENT OS   ·   Research</a:t>
+            </a:r>
+          </a:p>
+        </p:txBody>
+      </p:sp>
+      <p:sp>
+        <p:nvSpPr>
+          <p:cNvPr id="5" name="TextBox 4"/>
+          <p:cNvSpPr txBox="1"/>
+          <p:nvPr/>
+        </p:nvSpPr>
+        <p:spPr>
+          <a:xfrm>
+            <a:off x="365760" y="502920"/>
+            <a:ext cx="8412480" cy="731520"/>
+          </a:xfrm>
+          <a:prstGeom prst="rect">
+            <a:avLst/>
+          </a:prstGeom>
+          <a:noFill/>
+        </p:spPr>
+        <p:txBody>
+          <a:bodyPr wrap="square">
+            <a:spAutoFit/>
+          </a:bodyPr>
+          <a:lstStyle/>
+          <a:p>
+            <a:pPr algn="l"/>
+            <a:r>
+              <a:rPr sz="2600" b="0">
+                <a:solidFill>
+                  <a:srgbClr val="12160F"/>
+                </a:solidFill>
+                <a:latin typeface="Georgia"/>
+              </a:rPr>
+              <a:t>What we may say in a pack</a:t>
+            </a:r>
+          </a:p>
+        </p:txBody>
+      </p:sp>
+      <p:sp>
+        <p:nvSpPr>
+          <p:cNvPr id="6" name="TextBox 5"/>
+          <p:cNvSpPr txBox="1"/>
+          <p:nvPr/>
+        </p:nvSpPr>
+        <p:spPr>
+          <a:xfrm>
+            <a:off x="365760" y="1371600"/>
+            <a:ext cx="8321040" cy="4937760"/>
+          </a:xfrm>
+          <a:prstGeom prst="rect">
+            <a:avLst/>
+          </a:prstGeom>
+          <a:noFill/>
+        </p:spPr>
+        <p:txBody>
+          <a:bodyPr wrap="square">
+            <a:spAutoFit/>
+          </a:bodyPr>
+          <a:lstStyle/>
+          <a:p>
+            <a:pPr>
+              <a:spcAft>
+                <a:spcPts val="800"/>
+              </a:spcAft>
+            </a:pPr>
+            <a:r>
+              <a:rPr sz="1600">
+                <a:solidFill>
+                  <a:srgbClr val="12160F"/>
+                </a:solidFill>
+                <a:latin typeface="Calibri"/>
+              </a:rPr>
+              <a:t>·  McKinsey State of AI 2025 figures with sample and date.</a:t>
+            </a:r>
+          </a:p>
+          <a:p>
+            <a:pPr>
+              <a:spcAft>
+                <a:spcPts val="800"/>
+              </a:spcAft>
+            </a:pPr>
+            <a:r>
+              <a:rPr sz="1600">
+                <a:solidFill>
+                  <a:srgbClr val="12160F"/>
+                </a:solidFill>
+                <a:latin typeface="Calibri"/>
+              </a:rPr>
+              <a:t>·  High performers redesign workflows — that is the method.</a:t>
+            </a:r>
+          </a:p>
+          <a:p>
+            <a:pPr>
+              <a:spcAft>
+                <a:spcPts val="800"/>
+              </a:spcAft>
+            </a:pPr>
+            <a:r>
+              <a:rPr sz="1600">
+                <a:solidFill>
+                  <a:srgbClr val="12160F"/>
+                </a:solidFill>
+                <a:latin typeface="Calibri"/>
+              </a:rPr>
+              <a:t>·  Ardent via Tipalti is vendor-citing-independent. Not a before/after.</a:t>
+            </a:r>
+          </a:p>
+          <a:p>
+            <a:pPr>
+              <a:spcAft>
+                <a:spcPts val="800"/>
+              </a:spcAft>
+            </a:pPr>
+            <a:r>
+              <a:rPr sz="1600">
+                <a:solidFill>
+                  <a:srgbClr val="12160F"/>
+                </a:solidFill>
+                <a:latin typeface="Calibri"/>
+              </a:rPr>
+              <a:t>·  If a number is not in the research ledger, do not put it on a slide.</a:t>
+            </a:r>
+          </a:p>
+        </p:txBody>
+      </p:sp>
+    </p:spTree>
+  </p:cSld>
+  <p:clrMapOvr>
+    <a:masterClrMapping/>
+  </p:clrMapOvr>
+</p:sld>
+</file>
+
+<file path=ppt/slides/slide8.xml><?xml version="1.0" encoding="utf-8"?>
+<p:sld xmlns:a="http://schemas.openxmlformats.org/drawingml/2006/main" xmlns:p="http://schemas.openxmlformats.org/presentationml/2006/main" xmlns:r="http://schemas.openxmlformats.org/officeDocument/2006/relationships">
+  <p:cSld>
+    <p:spTree>
+      <p:nvGrpSpPr>
+        <p:cNvPr id="1" name=""/>
+        <p:cNvGrpSpPr/>
+        <p:nvPr/>
+      </p:nvGrpSpPr>
+      <p:grpSpPr/>
+      <p:sp>
+        <p:nvSpPr>
+          <p:cNvPr id="2" name="Rectangle 1"/>
+          <p:cNvSpPr/>
+          <p:nvPr/>
+        </p:nvSpPr>
+        <p:spPr>
+          <a:xfrm>
+            <a:off x="0" y="0"/>
+            <a:ext cx="9144000" cy="6858000"/>
+          </a:xfrm>
+          <a:prstGeom prst="rect">
+            <a:avLst/>
+          </a:prstGeom>
+          <a:solidFill>
+            <a:srgbClr val="F3EEE4"/>
+          </a:solidFill>
+          <a:ln>
+            <a:noFill/>
+          </a:ln>
+        </p:spPr>
+        <p:style>
+          <a:lnRef idx="1">
+            <a:schemeClr val="accent1"/>
+          </a:lnRef>
+          <a:fillRef idx="3">
+            <a:schemeClr val="accent1"/>
+          </a:fillRef>
+          <a:effectRef idx="2">
+            <a:schemeClr val="accent1"/>
+          </a:effectRef>
+          <a:fontRef idx="minor">
+            <a:schemeClr val="lt1"/>
+          </a:fontRef>
+        </p:style>
+        <p:txBody>
+          <a:bodyPr rtlCol="0" anchor="ctr"/>
+          <a:lstStyle/>
+          <a:p>
+            <a:pPr algn="ctr"/>
+          </a:p>
+        </p:txBody>
+      </p:sp>
+      <p:sp>
+        <p:nvSpPr>
+          <p:cNvPr id="3" name="Rectangle 2"/>
+          <p:cNvSpPr/>
+          <p:nvPr/>
+        </p:nvSpPr>
+        <p:spPr>
+          <a:xfrm>
+            <a:off x="0" y="0"/>
+            <a:ext cx="73152" cy="6858000"/>
+          </a:xfrm>
+          <a:prstGeom prst="rect">
+            <a:avLst/>
+          </a:prstGeom>
+          <a:solidFill>
+            <a:srgbClr val="B0893E"/>
+          </a:solidFill>
+          <a:ln>
+            <a:noFill/>
+          </a:ln>
+        </p:spPr>
+        <p:style>
+          <a:lnRef idx="1">
+            <a:schemeClr val="accent1"/>
+          </a:lnRef>
+          <a:fillRef idx="3">
+            <a:schemeClr val="accent1"/>
+          </a:fillRef>
+          <a:effectRef idx="2">
+            <a:schemeClr val="accent1"/>
+          </a:effectRef>
+          <a:fontRef idx="minor">
+            <a:schemeClr val="lt1"/>
+          </a:fontRef>
+        </p:style>
+        <p:txBody>
+          <a:bodyPr rtlCol="0" anchor="ctr"/>
+          <a:lstStyle/>
+          <a:p>
+            <a:pPr algn="ctr"/>
+          </a:p>
+        </p:txBody>
+      </p:sp>
+      <p:sp>
+        <p:nvSpPr>
+          <p:cNvPr id="4" name="TextBox 3"/>
+          <p:cNvSpPr txBox="1"/>
+          <p:nvPr/>
+        </p:nvSpPr>
+        <p:spPr>
+          <a:xfrm>
+            <a:off x="365760" y="164592"/>
+            <a:ext cx="8412480" cy="256032"/>
+          </a:xfrm>
+          <a:prstGeom prst="rect">
+            <a:avLst/>
+          </a:prstGeom>
+          <a:noFill/>
+        </p:spPr>
+        <p:txBody>
+          <a:bodyPr wrap="square">
+            <a:spAutoFit/>
+          </a:bodyPr>
+          <a:lstStyle/>
+          <a:p>
+            <a:pPr algn="l"/>
+            <a:r>
+              <a:rPr sz="1000" b="0">
+                <a:solidFill>
+                  <a:srgbClr val="B0893E"/>
+                </a:solidFill>
+                <a:latin typeface="Calibri"/>
+              </a:rPr>
+              <a:t>EVIDENCE ROOM — AP AGENT OS   ·   Decision</a:t>
+            </a:r>
+          </a:p>
+        </p:txBody>
+      </p:sp>
+      <p:sp>
+        <p:nvSpPr>
+          <p:cNvPr id="5" name="TextBox 4"/>
+          <p:cNvSpPr txBox="1"/>
+          <p:nvPr/>
+        </p:nvSpPr>
+        <p:spPr>
+          <a:xfrm>
+            <a:off x="365760" y="502920"/>
+            <a:ext cx="8412480" cy="731520"/>
+          </a:xfrm>
+          <a:prstGeom prst="rect">
+            <a:avLst/>
+          </a:prstGeom>
+          <a:noFill/>
+        </p:spPr>
+        <p:txBody>
+          <a:bodyPr wrap="square">
+            <a:spAutoFit/>
+          </a:bodyPr>
+          <a:lstStyle/>
+          <a:p>
+            <a:pPr algn="l"/>
+            <a:r>
+              <a:rPr sz="2600" b="0">
+                <a:solidFill>
+                  <a:srgbClr val="12160F"/>
+                </a:solidFill>
+                <a:latin typeface="Georgia"/>
+              </a:rPr>
+              <a:t>What a board can usefully decide</a:t>
+            </a:r>
+          </a:p>
+        </p:txBody>
+      </p:sp>
+      <p:sp>
+        <p:nvSpPr>
+          <p:cNvPr id="6" name="TextBox 5"/>
+          <p:cNvSpPr txBox="1"/>
+          <p:nvPr/>
+        </p:nvSpPr>
+        <p:spPr>
+          <a:xfrm>
+            <a:off x="365760" y="1371600"/>
+            <a:ext cx="8321040" cy="4937760"/>
+          </a:xfrm>
+          <a:prstGeom prst="rect">
+            <a:avLst/>
+          </a:prstGeom>
+          <a:noFill/>
+        </p:spPr>
+        <p:txBody>
+          <a:bodyPr wrap="square">
+            <a:spAutoFit/>
+          </a:bodyPr>
+          <a:lstStyle/>
+          <a:p>
+            <a:pPr>
+              <a:spcAft>
+                <a:spcPts val="800"/>
+              </a:spcAft>
+            </a:pPr>
+            <a:r>
+              <a:rPr sz="1600">
+                <a:solidFill>
+                  <a:srgbClr val="12160F"/>
+                </a:solidFill>
+                <a:latin typeface="Calibri"/>
+              </a:rPr>
+              <a:t>·  Fund a Wave 1 design and shadow — not a platform.</a:t>
+            </a:r>
+          </a:p>
+          <a:p>
+            <a:pPr>
+              <a:spcAft>
+                <a:spcPts val="800"/>
+              </a:spcAft>
+            </a:pPr>
+            <a:r>
+              <a:rPr sz="1600">
+                <a:solidFill>
+                  <a:srgbClr val="12160F"/>
+                </a:solidFill>
+                <a:latin typeface="Calibri"/>
+              </a:rPr>
+              <a:t>·  Name owners and a challenger.</a:t>
+            </a:r>
+          </a:p>
+          <a:p>
+            <a:pPr>
+              <a:spcAft>
+                <a:spcPts val="800"/>
+              </a:spcAft>
+            </a:pPr>
+            <a:r>
+              <a:rPr sz="1600">
+                <a:solidFill>
+                  <a:srgbClr val="12160F"/>
+                </a:solidFill>
+                <a:latin typeface="Calibri"/>
+              </a:rPr>
+              <a:t>·  Accept that remaining at L1 is success.</a:t>
+            </a:r>
+          </a:p>
+          <a:p>
+            <a:pPr>
+              <a:spcAft>
+                <a:spcPts val="800"/>
+              </a:spcAft>
+            </a:pPr>
+            <a:r>
+              <a:rPr sz="1600">
+                <a:solidFill>
+                  <a:srgbClr val="12160F"/>
+                </a:solidFill>
+                <a:latin typeface="Calibri"/>
+              </a:rPr>
+              <a:t>·  Refuse any frame that requires a guaranteed ROI to proceed.</a:t>
             </a:r>
           </a:p>
         </p:txBody>

</xml_diff>